<commit_message>
update ppt and html
</commit_message>
<xml_diff>
--- a/documents/visual_abstract_NER.pptx
+++ b/documents/visual_abstract_NER.pptx
@@ -9,9 +9,10 @@
     <p:sldId id="260" r:id="rId3"/>
     <p:sldId id="261" r:id="rId4"/>
     <p:sldId id="262" r:id="rId5"/>
-    <p:sldId id="257" r:id="rId6"/>
-    <p:sldId id="256" r:id="rId7"/>
-    <p:sldId id="259" r:id="rId8"/>
+    <p:sldId id="263" r:id="rId6"/>
+    <p:sldId id="257" r:id="rId7"/>
+    <p:sldId id="256" r:id="rId8"/>
+    <p:sldId id="259" r:id="rId9"/>
   </p:sldIdLst>
   <p:sldSz cx="9144000" cy="6858000" type="screen4x3"/>
   <p:notesSz cx="6858000" cy="9144000"/>
@@ -3326,8 +3327,8 @@
         </p:blipFill>
         <p:spPr>
           <a:xfrm>
-            <a:off x="2343060" y="235741"/>
-            <a:ext cx="4128696" cy="3193259"/>
+            <a:off x="2573648" y="0"/>
+            <a:ext cx="3032022" cy="2345058"/>
           </a:xfrm>
           <a:prstGeom prst="rect">
             <a:avLst/>
@@ -3738,6 +3739,286 @@
 </file>
 
 <file path=ppt/slides/slide5.xml><?xml version="1.0" encoding="utf-8"?>
+<p:sld xmlns:a="http://schemas.openxmlformats.org/drawingml/2006/main" xmlns:r="http://schemas.openxmlformats.org/officeDocument/2006/relationships" xmlns:p="http://schemas.openxmlformats.org/presentationml/2006/main">
+  <p:cSld>
+    <p:spTree>
+      <p:nvGrpSpPr>
+        <p:cNvPr id="1" name=""/>
+        <p:cNvGrpSpPr/>
+        <p:nvPr/>
+      </p:nvGrpSpPr>
+      <p:grpSpPr>
+        <a:xfrm>
+          <a:off x="0" y="0"/>
+          <a:ext cx="0" cy="0"/>
+          <a:chOff x="0" y="0"/>
+          <a:chExt cx="0" cy="0"/>
+        </a:xfrm>
+      </p:grpSpPr>
+      <p:sp>
+        <p:nvSpPr>
+          <p:cNvPr id="2" name="Titel 1">
+            <a:extLst>
+              <a:ext uri="{FF2B5EF4-FFF2-40B4-BE49-F238E27FC236}">
+                <a16:creationId xmlns:a16="http://schemas.microsoft.com/office/drawing/2014/main" id="{61658E02-7D76-13D4-8CD7-15DC687AADCB}"/>
+              </a:ext>
+            </a:extLst>
+          </p:cNvPr>
+          <p:cNvSpPr>
+            <a:spLocks noGrp="1"/>
+          </p:cNvSpPr>
+          <p:nvPr>
+            <p:ph type="title"/>
+          </p:nvPr>
+        </p:nvSpPr>
+        <p:spPr>
+          <a:xfrm>
+            <a:off x="0" y="20196"/>
+            <a:ext cx="8229600" cy="1143000"/>
+          </a:xfrm>
+        </p:spPr>
+        <p:txBody>
+          <a:bodyPr/>
+          <a:lstStyle/>
+          <a:p>
+            <a:r>
+              <a:rPr lang="de-DE" dirty="0" err="1"/>
+              <a:t>Let‘s</a:t>
+            </a:r>
+            <a:r>
+              <a:rPr lang="de-DE" dirty="0"/>
+              <a:t> </a:t>
+            </a:r>
+            <a:r>
+              <a:rPr lang="de-DE" dirty="0" err="1"/>
+              <a:t>start</a:t>
+            </a:r>
+            <a:r>
+              <a:rPr lang="de-DE" dirty="0"/>
+              <a:t>…</a:t>
+            </a:r>
+          </a:p>
+        </p:txBody>
+      </p:sp>
+      <p:sp>
+        <p:nvSpPr>
+          <p:cNvPr id="3" name="Textfeld 2">
+            <a:extLst>
+              <a:ext uri="{FF2B5EF4-FFF2-40B4-BE49-F238E27FC236}">
+                <a16:creationId xmlns:a16="http://schemas.microsoft.com/office/drawing/2014/main" id="{D73F6482-C271-9900-A6BE-CD2C18C44796}"/>
+              </a:ext>
+            </a:extLst>
+          </p:cNvPr>
+          <p:cNvSpPr txBox="1"/>
+          <p:nvPr/>
+        </p:nvSpPr>
+        <p:spPr>
+          <a:xfrm>
+            <a:off x="405517" y="1163196"/>
+            <a:ext cx="7450372" cy="4247317"/>
+          </a:xfrm>
+          <a:prstGeom prst="rect">
+            <a:avLst/>
+          </a:prstGeom>
+          <a:solidFill>
+            <a:schemeClr val="bg1">
+              <a:lumMod val="75000"/>
+            </a:schemeClr>
+          </a:solidFill>
+        </p:spPr>
+        <p:txBody>
+          <a:bodyPr wrap="square" rtlCol="0">
+            <a:spAutoFit/>
+          </a:bodyPr>
+          <a:lstStyle/>
+          <a:p>
+            <a:r>
+              <a:rPr lang="en-US" dirty="0">
+                <a:solidFill>
+                  <a:schemeClr val="tx2">
+                    <a:lumMod val="75000"/>
+                  </a:schemeClr>
+                </a:solidFill>
+              </a:rPr>
+              <a:t>CONFIG.py:</a:t>
+            </a:r>
+          </a:p>
+          <a:p>
+            <a:r>
+              <a:rPr lang="en-US" dirty="0">
+                <a:solidFill>
+                  <a:schemeClr val="tx2">
+                    <a:lumMod val="75000"/>
+                  </a:schemeClr>
+                </a:solidFill>
+              </a:rPr>
+              <a:t>There are defined the ENTITIES</a:t>
+            </a:r>
+          </a:p>
+          <a:p>
+            <a:endParaRPr lang="en-US" dirty="0">
+              <a:solidFill>
+                <a:schemeClr val="tx2">
+                  <a:lumMod val="75000"/>
+                </a:schemeClr>
+              </a:solidFill>
+            </a:endParaRPr>
+          </a:p>
+          <a:p>
+            <a:r>
+              <a:rPr lang="en-US" dirty="0">
+                <a:solidFill>
+                  <a:schemeClr val="tx2">
+                    <a:lumMod val="75000"/>
+                  </a:schemeClr>
+                </a:solidFill>
+              </a:rPr>
+              <a:t>DEFINITIONS.py</a:t>
+            </a:r>
+          </a:p>
+          <a:p>
+            <a:r>
+              <a:rPr lang="en-US" dirty="0">
+                <a:solidFill>
+                  <a:schemeClr val="tx2">
+                    <a:lumMod val="75000"/>
+                  </a:schemeClr>
+                </a:solidFill>
+              </a:rPr>
+              <a:t>There are defined the possible random values</a:t>
+            </a:r>
+          </a:p>
+          <a:p>
+            <a:endParaRPr lang="en-US" dirty="0">
+              <a:solidFill>
+                <a:schemeClr val="tx2">
+                  <a:lumMod val="75000"/>
+                </a:schemeClr>
+              </a:solidFill>
+            </a:endParaRPr>
+          </a:p>
+          <a:p>
+            <a:r>
+              <a:rPr lang="en-US" dirty="0">
+                <a:solidFill>
+                  <a:schemeClr val="tx2">
+                    <a:lumMod val="75000"/>
+                  </a:schemeClr>
+                </a:solidFill>
+              </a:rPr>
+              <a:t>TEMPLATES.py</a:t>
+            </a:r>
+          </a:p>
+          <a:p>
+            <a:r>
+              <a:rPr lang="en-US" dirty="0">
+                <a:solidFill>
+                  <a:schemeClr val="tx2">
+                    <a:lumMod val="75000"/>
+                  </a:schemeClr>
+                </a:solidFill>
+              </a:rPr>
+              <a:t>There are defined the Template for synthetic medical report</a:t>
+            </a:r>
+          </a:p>
+          <a:p>
+            <a:endParaRPr lang="en-US" dirty="0">
+              <a:solidFill>
+                <a:schemeClr val="tx2">
+                  <a:lumMod val="75000"/>
+                </a:schemeClr>
+              </a:solidFill>
+            </a:endParaRPr>
+          </a:p>
+          <a:p>
+            <a:endParaRPr lang="en-US" dirty="0">
+              <a:solidFill>
+                <a:schemeClr val="tx2">
+                  <a:lumMod val="75000"/>
+                </a:schemeClr>
+              </a:solidFill>
+            </a:endParaRPr>
+          </a:p>
+          <a:p>
+            <a:r>
+              <a:rPr lang="en-US" dirty="0">
+                <a:solidFill>
+                  <a:schemeClr val="tx2">
+                    <a:lumMod val="75000"/>
+                  </a:schemeClr>
+                </a:solidFill>
+              </a:rPr>
+              <a:t>Trainings data:</a:t>
+            </a:r>
+          </a:p>
+          <a:p>
+            <a:endParaRPr lang="en-US" dirty="0">
+              <a:solidFill>
+                <a:schemeClr val="tx2">
+                  <a:lumMod val="75000"/>
+                </a:schemeClr>
+              </a:solidFill>
+            </a:endParaRPr>
+          </a:p>
+          <a:p>
+            <a:r>
+              <a:rPr lang="en-US" dirty="0">
+                <a:solidFill>
+                  <a:schemeClr val="tx2">
+                    <a:lumMod val="75000"/>
+                  </a:schemeClr>
+                </a:solidFill>
+              </a:rPr>
+              <a:t>1: from template</a:t>
+            </a:r>
+          </a:p>
+          <a:p>
+            <a:r>
+              <a:rPr lang="en-US" dirty="0">
+                <a:solidFill>
+                  <a:schemeClr val="tx2">
+                    <a:lumMod val="75000"/>
+                  </a:schemeClr>
+                </a:solidFill>
+              </a:rPr>
+              <a:t>2: from paraphrase</a:t>
+            </a:r>
+          </a:p>
+          <a:p>
+            <a:r>
+              <a:rPr lang="en-US" dirty="0">
+                <a:solidFill>
+                  <a:schemeClr val="tx2">
+                    <a:lumMod val="75000"/>
+                  </a:schemeClr>
+                </a:solidFill>
+              </a:rPr>
+              <a:t>we have used 50% random...</a:t>
+            </a:r>
+            <a:endParaRPr lang="de-DE" dirty="0">
+              <a:solidFill>
+                <a:schemeClr val="tx2">
+                  <a:lumMod val="75000"/>
+                </a:schemeClr>
+              </a:solidFill>
+            </a:endParaRPr>
+          </a:p>
+        </p:txBody>
+      </p:sp>
+    </p:spTree>
+    <p:extLst>
+      <p:ext uri="{BB962C8B-B14F-4D97-AF65-F5344CB8AC3E}">
+        <p14:creationId xmlns:p14="http://schemas.microsoft.com/office/powerpoint/2010/main" val="1274361470"/>
+      </p:ext>
+    </p:extLst>
+  </p:cSld>
+  <p:clrMapOvr>
+    <a:masterClrMapping/>
+  </p:clrMapOvr>
+</p:sld>
+</file>
+
+<file path=ppt/slides/slide6.xml><?xml version="1.0" encoding="utf-8"?>
 <p:sld xmlns:a="http://schemas.openxmlformats.org/drawingml/2006/main" xmlns:r="http://schemas.openxmlformats.org/officeDocument/2006/relationships" xmlns:p="http://schemas.openxmlformats.org/presentationml/2006/main">
   <p:cSld>
     <p:spTree>
@@ -5418,7 +5699,7 @@
 </p:sld>
 </file>
 
-<file path=ppt/slides/slide6.xml><?xml version="1.0" encoding="utf-8"?>
+<file path=ppt/slides/slide7.xml><?xml version="1.0" encoding="utf-8"?>
 <p:sld xmlns:a="http://schemas.openxmlformats.org/drawingml/2006/main" xmlns:r="http://schemas.openxmlformats.org/officeDocument/2006/relationships" xmlns:p="http://schemas.openxmlformats.org/presentationml/2006/main">
   <p:cSld>
     <p:spTree>
@@ -5886,7 +6167,7 @@
 </p:sld>
 </file>
 
-<file path=ppt/slides/slide7.xml><?xml version="1.0" encoding="utf-8"?>
+<file path=ppt/slides/slide8.xml><?xml version="1.0" encoding="utf-8"?>
 <p:sld xmlns:a="http://schemas.openxmlformats.org/drawingml/2006/main" xmlns:r="http://schemas.openxmlformats.org/officeDocument/2006/relationships" xmlns:p="http://schemas.openxmlformats.org/presentationml/2006/main">
   <p:cSld>
     <p:spTree>

</xml_diff>